<commit_message>
Center CLUEWSC2020 on Chinese reference resolution and original evaluation
</commit_message>
<xml_diff>
--- a/slides/datasets-in-10-minutes-cluewsc2020.pptx
+++ b/slides/datasets-in-10-minutes-cluewsc2020.pptx
@@ -25,10 +25,8 @@
     <p:sldId id="274" r:id="rId24"/>
     <p:sldId id="275" r:id="rId25"/>
     <p:sldId id="276" r:id="rId26"/>
-    <p:sldId id="277" r:id="rId27"/>
     <p:sldId id="278" r:id="rId28"/>
     <p:sldId id="279" r:id="rId29"/>
-    <p:sldId id="280" r:id="rId30"/>
     <p:sldId id="282" r:id="rId32"/>
     <p:sldId id="283" r:id="rId33"/>
     <p:sldId id="284" r:id="rId34"/>
@@ -54,10 +52,8 @@
     <p:sldId id="307" r:id="rId57"/>
     <p:sldId id="308" r:id="rId58"/>
     <p:sldId id="311" r:id="rId61"/>
-    <p:sldId id="312" r:id="rId62"/>
     <p:sldId id="313" r:id="rId63"/>
     <p:sldId id="314" r:id="rId64"/>
-    <p:sldId id="315" r:id="rId65"/>
   </p:sldIdLst>
   <p:sldSz cx="9144000" cy="5143500" type="screen16x9"/>
   <p:notesSz cx="6858000" cy="9144000"/>
@@ -12074,36 +12070,6 @@
               <a:t>次のモデル性能は、構築時の2020年テスト290問に対する報告値。現在公開されているテストは2,574問に更新されている。</a:t>
             </a:r>
           </a:p>
-          <a:p>
-            <a:pPr marL="457200" indent="-355600">
-              <a:lnSpc>
-                <a:spcPts val="2320"/>
-              </a:lnSpc>
-              <a:spcAft>
-                <a:spcPts val="0"/>
-              </a:spcAft>
-              <a:buSzPct val="68205"/>
-              <a:buFont typeface="Noto Sans CJK JP"/>
-              <a:buChar char="●"/>
-              <a:defRPr sz="1950" b="0">
-                <a:solidFill>
-                  <a:srgbClr val="303437"/>
-                </a:solidFill>
-                <a:latin typeface="Noto Sans"/>
-              </a:defRPr>
-            </a:pPr>
-            <a:r>
-              <a:rPr sz="1950" b="0" lang="ja-JP" altLang="en-US">
-                <a:solidFill>
-                  <a:srgbClr val="303437"/>
-                </a:solidFill>
-                <a:latin typeface="Noto Sans"/>
-                <a:ea typeface="Noto Sans CJK JP"/>
-                <a:cs typeface="Noto Sans"/>
-              </a:rPr>
-              <a:t>CLEVAの共参照解決でも正答率を用い、言語モデルがプロンプトへ答える形で評価する。</a:t>
-            </a:r>
-          </a:p>
         </p:txBody>
       </p:sp>
       <p:sp>
@@ -12227,57 +12193,6 @@
                 <a:hlinkClick r:id="rId2"/>
               </a:rPr>
               <a:t>https://aclanthology.org/2020.coling-main.419/</a:t>
-            </a:r>
-          </a:p>
-          <a:p>
-            <a:pPr>
-              <a:lnSpc>
-                <a:spcPts val="940"/>
-              </a:lnSpc>
-              <a:spcAft>
-                <a:spcPts val="300"/>
-              </a:spcAft>
-              <a:buNone/>
-              <a:defRPr sz="810" b="0">
-                <a:solidFill>
-                  <a:srgbClr val="303437"/>
-                </a:solidFill>
-                <a:latin typeface="Noto Sans"/>
-              </a:defRPr>
-            </a:pPr>
-            <a:r>
-              <a:rPr sz="810" b="0" lang="ja-JP" altLang="en-US">
-                <a:solidFill>
-                  <a:srgbClr val="626669"/>
-                </a:solidFill>
-                <a:latin typeface="Noto Sans"/>
-                <a:ea typeface="Noto Sans CJK JP"/>
-                <a:cs typeface="Noto Sans"/>
-              </a:rPr>
-              <a:t>[2] Li et al. (2023). CLEVA: Chinese Language Models EVAluation Platform. EMNLP System Demonstrations.</a:t>
-            </a:r>
-            <a:r>
-              <a:rPr sz="810" b="0" lang="ja-JP" altLang="en-US">
-                <a:solidFill>
-                  <a:srgbClr val="626669"/>
-                </a:solidFill>
-                <a:latin typeface="Noto Sans"/>
-                <a:ea typeface="Noto Sans CJK JP"/>
-                <a:cs typeface="Noto Sans"/>
-              </a:rPr>
-              <a:t>  </a:t>
-            </a:r>
-            <a:r>
-              <a:rPr sz="810" b="0" lang="ja-JP" altLang="en-US">
-                <a:solidFill>
-                  <a:srgbClr val="626669"/>
-                </a:solidFill>
-                <a:latin typeface="Noto Sans"/>
-                <a:ea typeface="Noto Sans CJK JP"/>
-                <a:cs typeface="Noto Sans"/>
-                <a:hlinkClick r:id="rId3"/>
-              </a:rPr>
-              <a:t>https://aclanthology.org/2023.emnlp-demo.17/</a:t>
             </a:r>
           </a:p>
         </p:txBody>
@@ -13024,337 +12939,6 @@
 </p:sld>
 </file>
 
-<file path=ppt/slides/slide22.xml><?xml version="1.0" encoding="utf-8"?>
-<p:sld xmlns:a="http://schemas.openxmlformats.org/drawingml/2006/main" xmlns:p="http://schemas.openxmlformats.org/presentationml/2006/main" xmlns:r="http://schemas.openxmlformats.org/officeDocument/2006/relationships">
-  <p:cSld>
-    <p:spTree>
-      <p:nvGrpSpPr>
-        <p:cNvPr id="1" name=""/>
-        <p:cNvGrpSpPr/>
-        <p:nvPr/>
-      </p:nvGrpSpPr>
-      <p:grpSpPr/>
-      <p:sp>
-        <p:nvSpPr>
-          <p:cNvPr id="2" name="Title 1"/>
-          <p:cNvSpPr>
-            <a:spLocks noGrp="1"/>
-          </p:cNvSpPr>
-          <p:nvPr>
-            <p:ph type="title"/>
-          </p:nvPr>
-        </p:nvSpPr>
-        <p:spPr>
-          <a:xfrm>
-            <a:off x="468172" y="650138"/>
-            <a:ext cx="8206740" cy="616305"/>
-          </a:xfrm>
-        </p:spPr>
-        <p:txBody>
-          <a:bodyPr wrap="square" lIns="0" rIns="0" tIns="0" bIns="0">
-            <a:noAutofit/>
-          </a:bodyPr>
-          <a:lstStyle/>
-          <a:p>
-            <a:pPr algn="l">
-              <a:lnSpc>
-                <a:spcPct val="110000"/>
-              </a:lnSpc>
-              <a:buNone/>
-              <a:defRPr sz="2800" b="0">
-                <a:solidFill>
-                  <a:srgbClr val="303437"/>
-                </a:solidFill>
-                <a:latin typeface="Noto Sans"/>
-              </a:defRPr>
-            </a:pPr>
-            <a:r>
-              <a:rPr sz="2800" b="1" lang="ja-JP" altLang="en-US">
-                <a:solidFill>
-                  <a:srgbClr val="303437"/>
-                </a:solidFill>
-                <a:latin typeface="Noto Sans"/>
-                <a:ea typeface="Noto Sans CJK JP"/>
-                <a:cs typeface="Noto Sans"/>
-              </a:rPr>
-              <a:t>モデルは3回微調整し、開発成績で選ぶ</a:t>
-            </a:r>
-          </a:p>
-        </p:txBody>
-      </p:sp>
-      <p:sp>
-        <p:nvSpPr>
-          <p:cNvPr id="3" name="Text Placeholder 2"/>
-          <p:cNvSpPr>
-            <a:spLocks noGrp="1"/>
-          </p:cNvSpPr>
-          <p:nvPr>
-            <p:ph type="body" idx="1"/>
-          </p:nvPr>
-        </p:nvSpPr>
-        <p:spPr>
-          <a:xfrm>
-            <a:off x="594360" y="1463040"/>
-            <a:ext cx="7955279" cy="3044952"/>
-          </a:xfrm>
-        </p:spPr>
-        <p:txBody>
-          <a:bodyPr wrap="square" tIns="91440" bIns="91440">
-            <a:noAutofit/>
-          </a:bodyPr>
-          <a:lstStyle/>
-          <a:p>
-            <a:pPr marL="457200" indent="-355600">
-              <a:lnSpc>
-                <a:spcPts val="2261"/>
-              </a:lnSpc>
-              <a:spcAft>
-                <a:spcPts val="700"/>
-              </a:spcAft>
-              <a:buSzPct val="70000"/>
-              <a:buFont typeface="Noto Sans CJK JP"/>
-              <a:buChar char="●"/>
-              <a:defRPr sz="1900" b="0">
-                <a:solidFill>
-                  <a:srgbClr val="303437"/>
-                </a:solidFill>
-                <a:latin typeface="Noto Sans"/>
-              </a:defRPr>
-            </a:pPr>
-            <a:r>
-              <a:rPr sz="1900" b="0" lang="ja-JP" altLang="en-US">
-                <a:solidFill>
-                  <a:srgbClr val="303437"/>
-                </a:solidFill>
-                <a:latin typeface="Noto Sans"/>
-                <a:ea typeface="Noto Sans CJK JP"/>
-                <a:cs typeface="Noto Sans"/>
-              </a:rPr>
-              <a:t>各モデルを3回微調整し、開発データで最も良い成績を出したモデルのテスト値を報告した。</a:t>
-            </a:r>
-          </a:p>
-          <a:p>
-            <a:pPr marL="457200" indent="-355600">
-              <a:lnSpc>
-                <a:spcPts val="2261"/>
-              </a:lnSpc>
-              <a:spcAft>
-                <a:spcPts val="700"/>
-              </a:spcAft>
-              <a:buSzPct val="70000"/>
-              <a:buFont typeface="Noto Sans CJK JP"/>
-              <a:buChar char="●"/>
-              <a:defRPr sz="1900" b="0">
-                <a:solidFill>
-                  <a:srgbClr val="303437"/>
-                </a:solidFill>
-                <a:latin typeface="Noto Sans"/>
-              </a:defRPr>
-            </a:pPr>
-            <a:r>
-              <a:rPr sz="1900" b="0" lang="ja-JP" altLang="en-US">
-                <a:solidFill>
-                  <a:srgbClr val="303437"/>
-                </a:solidFill>
-                <a:latin typeface="Noto Sans"/>
-                <a:ea typeface="Noto Sans CJK JP"/>
-                <a:cs typeface="Noto Sans"/>
-              </a:rPr>
-              <a:t>この結果は、教師あり学習で指示関係を判定するモデルの歴史的な比較。後にCLEVAでは、生成モデルにプロンプトを与えて答えさせる課題としても利用された。</a:t>
-            </a:r>
-          </a:p>
-        </p:txBody>
-      </p:sp>
-      <p:sp>
-        <p:nvSpPr>
-          <p:cNvPr id="4" name="Title 3"/>
-          <p:cNvSpPr>
-            <a:spLocks noGrp="1"/>
-          </p:cNvSpPr>
-          <p:nvPr>
-            <p:ph type="title" idx="2"/>
-          </p:nvPr>
-        </p:nvSpPr>
-        <p:spPr>
-          <a:xfrm>
-            <a:off x="75895" y="0"/>
-            <a:ext cx="8115300" cy="480060"/>
-          </a:xfrm>
-        </p:spPr>
-        <p:txBody>
-          <a:bodyPr wrap="square" lIns="0" rIns="0" tIns="0" bIns="0" anchor="ctr">
-            <a:noAutofit/>
-          </a:bodyPr>
-          <a:lstStyle/>
-          <a:p>
-            <a:pPr algn="l">
-              <a:lnSpc>
-                <a:spcPct val="110000"/>
-              </a:lnSpc>
-              <a:buNone/>
-              <a:defRPr sz="1400" b="0">
-                <a:solidFill>
-                  <a:srgbClr val="303437"/>
-                </a:solidFill>
-                <a:latin typeface="Noto Sans"/>
-              </a:defRPr>
-            </a:pPr>
-            <a:r>
-              <a:rPr sz="1400" b="1" lang="ja-JP" altLang="en-US">
-                <a:solidFill>
-                  <a:srgbClr val="FFFEF8"/>
-                </a:solidFill>
-                <a:latin typeface="Noto Sans"/>
-                <a:ea typeface="Noto Sans CJK JP"/>
-                <a:cs typeface="Noto Sans"/>
-              </a:rPr>
-              <a:t>3. 評価と歴史的な性能</a:t>
-            </a:r>
-          </a:p>
-        </p:txBody>
-      </p:sp>
-      <p:sp>
-        <p:nvSpPr>
-          <p:cNvPr id="5" name="sources"/>
-          <p:cNvSpPr txBox="1"/>
-          <p:nvPr/>
-        </p:nvSpPr>
-        <p:spPr>
-          <a:xfrm>
-            <a:off x="502920" y="4517136"/>
-            <a:ext cx="8183879" cy="530352"/>
-          </a:xfrm>
-          <a:prstGeom prst="rect">
-            <a:avLst/>
-          </a:prstGeom>
-          <a:noFill/>
-        </p:spPr>
-        <p:txBody>
-          <a:bodyPr wrap="square" lIns="0" rIns="0" tIns="0" bIns="0">
-            <a:noAutofit/>
-          </a:bodyPr>
-          <a:lstStyle/>
-          <a:p>
-            <a:pPr algn="l">
-              <a:lnSpc>
-                <a:spcPts val="940"/>
-              </a:lnSpc>
-              <a:spcBef>
-                <a:spcPts val="0"/>
-              </a:spcBef>
-              <a:spcAft>
-                <a:spcPts val="300"/>
-              </a:spcAft>
-              <a:buNone/>
-              <a:defRPr sz="810" b="0">
-                <a:solidFill>
-                  <a:srgbClr val="303437"/>
-                </a:solidFill>
-                <a:latin typeface="Noto Sans"/>
-              </a:defRPr>
-            </a:pPr>
-            <a:r>
-              <a:rPr sz="810" b="0" lang="ja-JP" altLang="en-US">
-                <a:solidFill>
-                  <a:srgbClr val="626669"/>
-                </a:solidFill>
-                <a:latin typeface="Noto Sans"/>
-                <a:ea typeface="Noto Sans CJK JP"/>
-                <a:cs typeface="Noto Sans"/>
-              </a:rPr>
-              <a:t>[1] Xu et al. (2020). CLUE: A Chinese Language Understanding Evaluation Benchmark. COLING, pp.4762–4772.</a:t>
-            </a:r>
-            <a:r>
-              <a:rPr sz="810" b="0" lang="ja-JP" altLang="en-US">
-                <a:solidFill>
-                  <a:srgbClr val="626669"/>
-                </a:solidFill>
-                <a:latin typeface="Noto Sans"/>
-                <a:ea typeface="Noto Sans CJK JP"/>
-                <a:cs typeface="Noto Sans"/>
-              </a:rPr>
-              <a:t>  </a:t>
-            </a:r>
-            <a:r>
-              <a:rPr sz="810" b="0" lang="ja-JP" altLang="en-US">
-                <a:solidFill>
-                  <a:srgbClr val="626669"/>
-                </a:solidFill>
-                <a:latin typeface="Noto Sans"/>
-                <a:ea typeface="Noto Sans CJK JP"/>
-                <a:cs typeface="Noto Sans"/>
-                <a:hlinkClick r:id="rId2"/>
-              </a:rPr>
-              <a:t>https://aclanthology.org/2020.coling-main.419/</a:t>
-            </a:r>
-          </a:p>
-          <a:p>
-            <a:pPr>
-              <a:lnSpc>
-                <a:spcPts val="940"/>
-              </a:lnSpc>
-              <a:spcAft>
-                <a:spcPts val="300"/>
-              </a:spcAft>
-              <a:buNone/>
-              <a:defRPr sz="810" b="0">
-                <a:solidFill>
-                  <a:srgbClr val="303437"/>
-                </a:solidFill>
-                <a:latin typeface="Noto Sans"/>
-              </a:defRPr>
-            </a:pPr>
-            <a:r>
-              <a:rPr sz="810" b="0" lang="ja-JP" altLang="en-US">
-                <a:solidFill>
-                  <a:srgbClr val="626669"/>
-                </a:solidFill>
-                <a:latin typeface="Noto Sans"/>
-                <a:ea typeface="Noto Sans CJK JP"/>
-                <a:cs typeface="Noto Sans"/>
-              </a:rPr>
-              <a:t>[2] CLUE team. CLUEWSC2020: WSC Winograd模式挑战中文版，中文指代消解任务.</a:t>
-            </a:r>
-          </a:p>
-          <a:p>
-            <a:pPr>
-              <a:lnSpc>
-                <a:spcPts val="940"/>
-              </a:lnSpc>
-              <a:spcAft>
-                <a:spcPts val="300"/>
-              </a:spcAft>
-              <a:buNone/>
-              <a:defRPr sz="810" b="0">
-                <a:solidFill>
-                  <a:srgbClr val="303437"/>
-                </a:solidFill>
-                <a:latin typeface="Noto Sans"/>
-              </a:defRPr>
-            </a:pPr>
-            <a:r>
-              <a:rPr sz="810" b="0" lang="ja-JP" altLang="en-US">
-                <a:solidFill>
-                  <a:srgbClr val="626669"/>
-                </a:solidFill>
-                <a:latin typeface="Noto Sans"/>
-                <a:ea typeface="Noto Sans CJK JP"/>
-                <a:cs typeface="Noto Sans"/>
-                <a:hlinkClick r:id="rId3"/>
-              </a:rPr>
-              <a:t>https://github.com/CLUEbenchmark/CLUEWSC2020/blob/446646278671444c79a67e7434b3a1d1d1cbbe88/README.md</a:t>
-            </a:r>
-          </a:p>
-        </p:txBody>
-      </p:sp>
-    </p:spTree>
-  </p:cSld>
-  <p:clrMapOvr>
-    <a:masterClrMapping/>
-  </p:clrMapOvr>
-</p:sld>
-</file>
-
 <file path=ppt/slides/slide23.xml><?xml version="1.0" encoding="utf-8"?>
 <p:sld xmlns:a="http://schemas.openxmlformats.org/drawingml/2006/main" xmlns:p="http://schemas.openxmlformats.org/presentationml/2006/main" xmlns:r="http://schemas.openxmlformats.org/officeDocument/2006/relationships">
   <p:cSld>
@@ -13408,7 +12992,7 @@
                 <a:ea typeface="Noto Sans CJK JP"/>
                 <a:cs typeface="Noto Sans"/>
               </a:rPr>
-              <a:t>中国語の指示関係を、モデル評価へ</a:t>
+              <a:t>4. 課題の特徴と利用条件</a:t>
             </a:r>
           </a:p>
         </p:txBody>
@@ -13456,7 +13040,7 @@
                 <a:ea typeface="Noto Sans CJK JP"/>
                 <a:cs typeface="Noto Sans"/>
               </a:rPr>
-              <a:t>4. CLUEとCLEVAでの利用</a:t>
+              <a:t>4. 課題の特徴と利用条件</a:t>
             </a:r>
           </a:p>
         </p:txBody>
@@ -13683,7 +13267,7 @@
                 <a:ea typeface="Noto Sans CJK JP"/>
                 <a:cs typeface="Noto Sans"/>
               </a:rPr>
-              <a:t>4. CLUEとCLEVAでの利用</a:t>
+              <a:t>4. 課題の特徴と利用条件</a:t>
             </a:r>
           </a:p>
         </p:txBody>
@@ -13812,367 +13396,6 @@
                 <a:hlinkClick r:id="rId3"/>
               </a:rPr>
               <a:t>https://aclanthology.org/2020.coling-main.419/</a:t>
-            </a:r>
-          </a:p>
-        </p:txBody>
-      </p:sp>
-    </p:spTree>
-  </p:cSld>
-  <p:clrMapOvr>
-    <a:masterClrMapping/>
-  </p:clrMapOvr>
-</p:sld>
-</file>
-
-<file path=ppt/slides/slide25.xml><?xml version="1.0" encoding="utf-8"?>
-<p:sld xmlns:a="http://schemas.openxmlformats.org/drawingml/2006/main" xmlns:p="http://schemas.openxmlformats.org/presentationml/2006/main" xmlns:r="http://schemas.openxmlformats.org/officeDocument/2006/relationships">
-  <p:cSld>
-    <p:spTree>
-      <p:nvGrpSpPr>
-        <p:cNvPr id="1" name=""/>
-        <p:cNvGrpSpPr/>
-        <p:nvPr/>
-      </p:nvGrpSpPr>
-      <p:grpSpPr/>
-      <p:sp>
-        <p:nvSpPr>
-          <p:cNvPr id="2" name="Title 1"/>
-          <p:cNvSpPr>
-            <a:spLocks noGrp="1"/>
-          </p:cNvSpPr>
-          <p:nvPr>
-            <p:ph type="title"/>
-          </p:nvPr>
-        </p:nvSpPr>
-        <p:spPr>
-          <a:xfrm>
-            <a:off x="468172" y="650138"/>
-            <a:ext cx="8206740" cy="616305"/>
-          </a:xfrm>
-        </p:spPr>
-        <p:txBody>
-          <a:bodyPr wrap="square" lIns="0" rIns="0" tIns="0" bIns="0">
-            <a:noAutofit/>
-          </a:bodyPr>
-          <a:lstStyle/>
-          <a:p>
-            <a:pPr algn="l">
-              <a:lnSpc>
-                <a:spcPct val="110000"/>
-              </a:lnSpc>
-              <a:buNone/>
-              <a:defRPr sz="2800" b="0">
-                <a:solidFill>
-                  <a:srgbClr val="303437"/>
-                </a:solidFill>
-                <a:latin typeface="Noto Sans"/>
-              </a:defRPr>
-            </a:pPr>
-            <a:r>
-              <a:rPr sz="2800" b="1" lang="ja-JP" altLang="en-US">
-                <a:solidFill>
-                  <a:srgbClr val="303437"/>
-                </a:solidFill>
-                <a:latin typeface="Noto Sans"/>
-                <a:ea typeface="Noto Sans CJK JP"/>
-                <a:cs typeface="Noto Sans"/>
-              </a:rPr>
-              <a:t>CLEVAは、CLUEWSCから問題を採用</a:t>
-            </a:r>
-          </a:p>
-        </p:txBody>
-      </p:sp>
-      <p:sp>
-        <p:nvSpPr>
-          <p:cNvPr id="3" name="Text Placeholder 2"/>
-          <p:cNvSpPr>
-            <a:spLocks noGrp="1"/>
-          </p:cNvSpPr>
-          <p:nvPr>
-            <p:ph type="body" idx="1"/>
-          </p:nvPr>
-        </p:nvSpPr>
-        <p:spPr>
-          <a:xfrm>
-            <a:off x="594360" y="1463040"/>
-            <a:ext cx="7955279" cy="3044952"/>
-          </a:xfrm>
-        </p:spPr>
-        <p:txBody>
-          <a:bodyPr wrap="square" tIns="91440" bIns="91440">
-            <a:noAutofit/>
-          </a:bodyPr>
-          <a:lstStyle/>
-          <a:p>
-            <a:pPr marL="457200" indent="-355600">
-              <a:lnSpc>
-                <a:spcPts val="2261"/>
-              </a:lnSpc>
-              <a:spcAft>
-                <a:spcPts val="700"/>
-              </a:spcAft>
-              <a:buSzPct val="70000"/>
-              <a:buFont typeface="Noto Sans CJK JP"/>
-              <a:buChar char="●"/>
-              <a:defRPr sz="1900" b="0">
-                <a:solidFill>
-                  <a:srgbClr val="303437"/>
-                </a:solidFill>
-                <a:latin typeface="Noto Sans"/>
-              </a:defRPr>
-            </a:pPr>
-            <a:r>
-              <a:rPr sz="1900" b="0" lang="ja-JP" altLang="en-US">
-                <a:solidFill>
-                  <a:srgbClr val="303437"/>
-                </a:solidFill>
-                <a:latin typeface="Noto Sans"/>
-                <a:ea typeface="Noto Sans CJK JP"/>
-                <a:cs typeface="Noto Sans"/>
-              </a:rPr>
-              <a:t>CLEVAは、CLUEWSCから抽出した問題を共参照解決の評価に使う。論文に掲載された例が、本資料の実例2に当たる。</a:t>
-            </a:r>
-          </a:p>
-          <a:p>
-            <a:pPr marL="457200" indent="-355600">
-              <a:lnSpc>
-                <a:spcPts val="2261"/>
-              </a:lnSpc>
-              <a:spcAft>
-                <a:spcPts val="700"/>
-              </a:spcAft>
-              <a:buSzPct val="70000"/>
-              <a:buFont typeface="Noto Sans CJK JP"/>
-              <a:buChar char="●"/>
-              <a:defRPr sz="1900" b="0">
-                <a:solidFill>
-                  <a:srgbClr val="303437"/>
-                </a:solidFill>
-                <a:latin typeface="Noto Sans"/>
-              </a:defRPr>
-            </a:pPr>
-            <a:r>
-              <a:rPr sz="1900" b="0" lang="ja-JP" altLang="en-US">
-                <a:solidFill>
-                  <a:srgbClr val="303437"/>
-                </a:solidFill>
-                <a:latin typeface="Noto Sans"/>
-                <a:ea typeface="Noto Sans CJK JP"/>
-                <a:cs typeface="Noto Sans"/>
-              </a:rPr>
-              <a:t>HELMのCLEVA実装では、プロンプトに文章と問いを組み込み、回答候補を用意する。実例1は「不是／是」の二候補を使う説明例として載っている。</a:t>
-            </a:r>
-          </a:p>
-          <a:p>
-            <a:pPr marL="457200" indent="-355600">
-              <a:lnSpc>
-                <a:spcPts val="2261"/>
-              </a:lnSpc>
-              <a:spcAft>
-                <a:spcPts val="0"/>
-              </a:spcAft>
-              <a:buSzPct val="70000"/>
-              <a:buFont typeface="Noto Sans CJK JP"/>
-              <a:buChar char="●"/>
-              <a:defRPr sz="1900" b="0">
-                <a:solidFill>
-                  <a:srgbClr val="303437"/>
-                </a:solidFill>
-                <a:latin typeface="Noto Sans"/>
-              </a:defRPr>
-            </a:pPr>
-            <a:r>
-              <a:rPr sz="1900" b="0" lang="ja-JP" altLang="en-US">
-                <a:solidFill>
-                  <a:srgbClr val="303437"/>
-                </a:solidFill>
-                <a:latin typeface="Noto Sans"/>
-                <a:ea typeface="Noto Sans CJK JP"/>
-                <a:cs typeface="Noto Sans"/>
-              </a:rPr>
-              <a:t>CLEVAで選定された全問題や推論条件の詳細は確認できないため、ここでは元のCLUEWSC2020の構成と、公開されている利用方法を紹介する。</a:t>
-            </a:r>
-          </a:p>
-        </p:txBody>
-      </p:sp>
-      <p:sp>
-        <p:nvSpPr>
-          <p:cNvPr id="4" name="Title 3"/>
-          <p:cNvSpPr>
-            <a:spLocks noGrp="1"/>
-          </p:cNvSpPr>
-          <p:nvPr>
-            <p:ph type="title" idx="2"/>
-          </p:nvPr>
-        </p:nvSpPr>
-        <p:spPr>
-          <a:xfrm>
-            <a:off x="75895" y="0"/>
-            <a:ext cx="8115300" cy="480060"/>
-          </a:xfrm>
-        </p:spPr>
-        <p:txBody>
-          <a:bodyPr wrap="square" lIns="0" rIns="0" tIns="0" bIns="0" anchor="ctr">
-            <a:noAutofit/>
-          </a:bodyPr>
-          <a:lstStyle/>
-          <a:p>
-            <a:pPr algn="l">
-              <a:lnSpc>
-                <a:spcPct val="110000"/>
-              </a:lnSpc>
-              <a:buNone/>
-              <a:defRPr sz="1400" b="0">
-                <a:solidFill>
-                  <a:srgbClr val="303437"/>
-                </a:solidFill>
-                <a:latin typeface="Noto Sans"/>
-              </a:defRPr>
-            </a:pPr>
-            <a:r>
-              <a:rPr sz="1400" b="1" lang="ja-JP" altLang="en-US">
-                <a:solidFill>
-                  <a:srgbClr val="FFFEF8"/>
-                </a:solidFill>
-                <a:latin typeface="Noto Sans"/>
-                <a:ea typeface="Noto Sans CJK JP"/>
-                <a:cs typeface="Noto Sans"/>
-              </a:rPr>
-              <a:t>4. CLUEとCLEVAでの利用</a:t>
-            </a:r>
-          </a:p>
-        </p:txBody>
-      </p:sp>
-      <p:sp>
-        <p:nvSpPr>
-          <p:cNvPr id="5" name="sources"/>
-          <p:cNvSpPr txBox="1"/>
-          <p:nvPr/>
-        </p:nvSpPr>
-        <p:spPr>
-          <a:xfrm>
-            <a:off x="502920" y="4517136"/>
-            <a:ext cx="8183879" cy="530352"/>
-          </a:xfrm>
-          <a:prstGeom prst="rect">
-            <a:avLst/>
-          </a:prstGeom>
-          <a:noFill/>
-        </p:spPr>
-        <p:txBody>
-          <a:bodyPr wrap="square" lIns="0" rIns="0" tIns="0" bIns="0">
-            <a:noAutofit/>
-          </a:bodyPr>
-          <a:lstStyle/>
-          <a:p>
-            <a:pPr algn="l">
-              <a:lnSpc>
-                <a:spcPts val="940"/>
-              </a:lnSpc>
-              <a:spcBef>
-                <a:spcPts val="0"/>
-              </a:spcBef>
-              <a:spcAft>
-                <a:spcPts val="300"/>
-              </a:spcAft>
-              <a:buNone/>
-              <a:defRPr sz="810" b="0">
-                <a:solidFill>
-                  <a:srgbClr val="303437"/>
-                </a:solidFill>
-                <a:latin typeface="Noto Sans"/>
-              </a:defRPr>
-            </a:pPr>
-            <a:r>
-              <a:rPr sz="810" b="0" lang="ja-JP" altLang="en-US">
-                <a:solidFill>
-                  <a:srgbClr val="626669"/>
-                </a:solidFill>
-                <a:latin typeface="Noto Sans"/>
-                <a:ea typeface="Noto Sans CJK JP"/>
-                <a:cs typeface="Noto Sans"/>
-              </a:rPr>
-              <a:t>[1] Li et al. (2023). CLEVA: Chinese Language Models EVAluation Platform. EMNLP System Demonstrations.</a:t>
-            </a:r>
-            <a:r>
-              <a:rPr sz="810" b="0" lang="ja-JP" altLang="en-US">
-                <a:solidFill>
-                  <a:srgbClr val="626669"/>
-                </a:solidFill>
-                <a:latin typeface="Noto Sans"/>
-                <a:ea typeface="Noto Sans CJK JP"/>
-                <a:cs typeface="Noto Sans"/>
-              </a:rPr>
-              <a:t>  </a:t>
-            </a:r>
-            <a:r>
-              <a:rPr sz="810" b="0" lang="ja-JP" altLang="en-US">
-                <a:solidFill>
-                  <a:srgbClr val="626669"/>
-                </a:solidFill>
-                <a:latin typeface="Noto Sans"/>
-                <a:ea typeface="Noto Sans CJK JP"/>
-                <a:cs typeface="Noto Sans"/>
-                <a:hlinkClick r:id="rId2"/>
-              </a:rPr>
-              <a:t>https://aclanthology.org/2023.emnlp-demo.17/</a:t>
-            </a:r>
-          </a:p>
-          <a:p>
-            <a:pPr>
-              <a:lnSpc>
-                <a:spcPts val="940"/>
-              </a:lnSpc>
-              <a:spcAft>
-                <a:spcPts val="300"/>
-              </a:spcAft>
-              <a:buNone/>
-              <a:defRPr sz="810" b="0">
-                <a:solidFill>
-                  <a:srgbClr val="303437"/>
-                </a:solidFill>
-                <a:latin typeface="Noto Sans"/>
-              </a:defRPr>
-            </a:pPr>
-            <a:r>
-              <a:rPr sz="810" b="0" lang="ja-JP" altLang="en-US">
-                <a:solidFill>
-                  <a:srgbClr val="626669"/>
-                </a:solidFill>
-                <a:latin typeface="Noto Sans"/>
-                <a:ea typeface="Noto Sans CJK JP"/>
-                <a:cs typeface="Noto Sans"/>
-              </a:rPr>
-              <a:t>[2] Stanford CRFM. CLEVACoreferenceResolutionScenario / Converter. HELM v0.4.0.</a:t>
-            </a:r>
-          </a:p>
-          <a:p>
-            <a:pPr>
-              <a:lnSpc>
-                <a:spcPts val="940"/>
-              </a:lnSpc>
-              <a:spcAft>
-                <a:spcPts val="300"/>
-              </a:spcAft>
-              <a:buNone/>
-              <a:defRPr sz="810" b="0">
-                <a:solidFill>
-                  <a:srgbClr val="303437"/>
-                </a:solidFill>
-                <a:latin typeface="Noto Sans"/>
-              </a:defRPr>
-            </a:pPr>
-            <a:r>
-              <a:rPr sz="810" b="0" lang="ja-JP" altLang="en-US">
-                <a:solidFill>
-                  <a:srgbClr val="626669"/>
-                </a:solidFill>
-                <a:latin typeface="Noto Sans"/>
-                <a:ea typeface="Noto Sans CJK JP"/>
-                <a:cs typeface="Noto Sans"/>
-                <a:hlinkClick r:id="rId3"/>
-              </a:rPr>
-              <a:t>https://github.com/stanford-crfm/helm/blob/v0.4.0/src/helm/benchmark/scenarios/cleva_scenario.py</a:t>
             </a:r>
           </a:p>
         </p:txBody>
@@ -14369,7 +13592,7 @@
                 <a:ea typeface="Noto Sans CJK JP"/>
                 <a:cs typeface="Noto Sans"/>
               </a:rPr>
-              <a:t>4. CLUEとCLEVAでの利用</a:t>
+              <a:t>4. 課題の特徴と利用条件</a:t>
             </a:r>
           </a:p>
         </p:txBody>
@@ -14682,7 +13905,7 @@
                 <a:ea typeface="Noto Sans CJK JP"/>
                 <a:cs typeface="Noto Sans"/>
               </a:rPr>
-              <a:t>構築時のテストでは最良モデルの正答率が81.38％、100問の人手評価は多数決で98％だった。中国語理解の課題として、CLUEからCLEVAへと利用が広がった。</a:t>
+              <a:t>構築時のテストでは最良モデルの正答率が81.38％、100問の人手評価は多数決で98％だった。文章と指定された二つの語句を合わせて、中国語の文脈理解を調べる。</a:t>
             </a:r>
           </a:p>
         </p:txBody>
@@ -14730,7 +13953,7 @@
                 <a:ea typeface="Noto Sans CJK JP"/>
                 <a:cs typeface="Noto Sans"/>
               </a:rPr>
-              <a:t>4. CLUEとCLEVAでの利用</a:t>
+              <a:t>4. 課題の特徴と利用条件</a:t>
             </a:r>
           </a:p>
         </p:txBody>
@@ -15130,7 +14353,7 @@
                 <a:ea typeface="Noto Sans CJK JP"/>
                 <a:cs typeface="Noto Sans"/>
               </a:rPr>
-              <a:t>CLUEとCLEVAでの利用</a:t>
+              <a:t>課題の特徴と利用条件</a:t>
             </a:r>
           </a:p>
         </p:txBody>
@@ -28100,7 +27323,7 @@
                 <a:ea typeface="Noto Sans CJK JP"/>
                 <a:cs typeface="Noto Sans"/>
               </a:rPr>
-              <a:t>2020年にCLUEの新しい指示関係課題として公開され、後にCLEVAの共参照解決にも採用された。</a:t>
+              <a:t>CLUEチームが2020年に公開した、中国語の自然な文脈で指示関係を調べる課題である。</a:t>
             </a:r>
           </a:p>
         </p:txBody>
@@ -28232,57 +27455,6 @@
                 <a:hlinkClick r:id="rId2"/>
               </a:rPr>
               <a:t>https://github.com/CLUEbenchmark/CLUEWSC2020/blob/446646278671444c79a67e7434b3a1d1d1cbbe88/README.md</a:t>
-            </a:r>
-          </a:p>
-          <a:p>
-            <a:pPr>
-              <a:lnSpc>
-                <a:spcPts val="940"/>
-              </a:lnSpc>
-              <a:spcAft>
-                <a:spcPts val="300"/>
-              </a:spcAft>
-              <a:buNone/>
-              <a:defRPr sz="810" b="0">
-                <a:solidFill>
-                  <a:srgbClr val="303437"/>
-                </a:solidFill>
-                <a:latin typeface="Noto Sans"/>
-              </a:defRPr>
-            </a:pPr>
-            <a:r>
-              <a:rPr sz="810" b="0" lang="ja-JP" altLang="en-US">
-                <a:solidFill>
-                  <a:srgbClr val="626669"/>
-                </a:solidFill>
-                <a:latin typeface="Noto Sans"/>
-                <a:ea typeface="Noto Sans CJK JP"/>
-                <a:cs typeface="Noto Sans"/>
-              </a:rPr>
-              <a:t>[2] Li et al. (2023). CLEVA: Chinese Language Models EVAluation Platform. EMNLP System Demonstrations.</a:t>
-            </a:r>
-            <a:r>
-              <a:rPr sz="810" b="0" lang="ja-JP" altLang="en-US">
-                <a:solidFill>
-                  <a:srgbClr val="626669"/>
-                </a:solidFill>
-                <a:latin typeface="Noto Sans"/>
-                <a:ea typeface="Noto Sans CJK JP"/>
-                <a:cs typeface="Noto Sans"/>
-              </a:rPr>
-              <a:t>  </a:t>
-            </a:r>
-            <a:r>
-              <a:rPr sz="810" b="0" lang="ja-JP" altLang="en-US">
-                <a:solidFill>
-                  <a:srgbClr val="626669"/>
-                </a:solidFill>
-                <a:latin typeface="Noto Sans"/>
-                <a:ea typeface="Noto Sans CJK JP"/>
-                <a:cs typeface="Noto Sans"/>
-                <a:hlinkClick r:id="rId3"/>
-              </a:rPr>
-              <a:t>https://aclanthology.org/2023.emnlp-demo.17/</a:t>
             </a:r>
           </a:p>
         </p:txBody>
@@ -28348,7 +27520,7 @@
                 <a:ea typeface="Noto Sans CJK JP"/>
                 <a:cs typeface="Noto Sans"/>
               </a:rPr>
-              <a:t>正式論文で報告された9モデルの精度</a:t>
+              <a:t>2020年：モデル別のテスト正答率（1/2）</a:t>
             </a:r>
           </a:p>
         </p:txBody>
@@ -29110,7 +28282,7 @@
                 <a:ea typeface="Noto Sans CJK JP"/>
                 <a:cs typeface="Noto Sans"/>
               </a:rPr>
-              <a:t>2020年のテスト290問に対する正答率。3回の微調整から、開発成績が最良のモデルを選択。</a:t>
+              <a:t>2020年のテスト290問に対する正答率。開発成績に基づいて選んだモデルを評価。</a:t>
             </a:r>
           </a:p>
         </p:txBody>
@@ -29253,7 +28425,7 @@
                 <a:ea typeface="Noto Sans CJK JP"/>
                 <a:cs typeface="Noto Sans"/>
               </a:rPr>
-              <a:t>正式論文で報告された9モデルの精度</a:t>
+              <a:t>2020年：モデル別のテスト正答率（2/2）</a:t>
             </a:r>
           </a:p>
         </p:txBody>
@@ -29913,7 +29085,7 @@
                 <a:ea typeface="Noto Sans CJK JP"/>
                 <a:cs typeface="Noto Sans"/>
               </a:rPr>
-              <a:t>2020年のテスト290問に対する正答率。3回の微調整から、開発成績が最良のモデルを選択。</a:t>
+              <a:t>2020年のテスト290問に対する正答率。開発成績に基づいて選んだモデルを評価。</a:t>
             </a:r>
           </a:p>
         </p:txBody>
@@ -30117,7 +29289,7 @@
         </p:nvSpPr>
         <p:spPr>
           <a:xfrm>
-            <a:off x="548640" y="1536192"/>
+            <a:off x="548640" y="1510792"/>
             <a:ext cx="8046720" cy="1673352"/>
           </a:xfrm>
           <a:prstGeom prst="rect">
@@ -30146,7 +29318,7 @@
           </a:fontRef>
         </p:style>
         <p:txBody>
-          <a:bodyPr rtlCol="0" anchor="t" wrap="none" lIns="152400" rIns="152400" tIns="54525" bIns="127000">
+          <a:bodyPr rtlCol="0" anchor="t" wrap="none" lIns="152400" rIns="152400" tIns="79925" bIns="127000">
             <a:noAutofit/>
           </a:bodyPr>
           <a:lstStyle/>
@@ -30610,310 +29782,6 @@
                 <a:cs typeface="Noto Sans"/>
               </a:rPr>
               <a:t>Appendix: 3. 研究と参考文献</a:t>
-            </a:r>
-          </a:p>
-        </p:txBody>
-      </p:sp>
-    </p:spTree>
-  </p:cSld>
-  <p:clrMapOvr>
-    <a:masterClrMapping/>
-  </p:clrMapOvr>
-</p:sld>
-</file>
-
-<file path=ppt/slides/slide57.xml><?xml version="1.0" encoding="utf-8"?>
-<p:sld xmlns:a="http://schemas.openxmlformats.org/drawingml/2006/main" xmlns:p="http://schemas.openxmlformats.org/presentationml/2006/main" xmlns:r="http://schemas.openxmlformats.org/officeDocument/2006/relationships">
-  <p:cSld>
-    <p:spTree>
-      <p:nvGrpSpPr>
-        <p:cNvPr id="1" name=""/>
-        <p:cNvGrpSpPr/>
-        <p:nvPr/>
-      </p:nvGrpSpPr>
-      <p:grpSpPr/>
-      <p:sp>
-        <p:nvSpPr>
-          <p:cNvPr id="2" name="Title 1"/>
-          <p:cNvSpPr>
-            <a:spLocks noGrp="1"/>
-          </p:cNvSpPr>
-          <p:nvPr>
-            <p:ph type="title"/>
-          </p:nvPr>
-        </p:nvSpPr>
-        <p:spPr>
-          <a:xfrm>
-            <a:off x="468172" y="650138"/>
-            <a:ext cx="8206740" cy="616305"/>
-          </a:xfrm>
-        </p:spPr>
-        <p:txBody>
-          <a:bodyPr wrap="square" lIns="0" rIns="0" tIns="0" bIns="0">
-            <a:noAutofit/>
-          </a:bodyPr>
-          <a:lstStyle/>
-          <a:p>
-            <a:pPr algn="l">
-              <a:lnSpc>
-                <a:spcPct val="110000"/>
-              </a:lnSpc>
-              <a:buNone/>
-              <a:defRPr sz="2800" b="0">
-                <a:solidFill>
-                  <a:srgbClr val="303437"/>
-                </a:solidFill>
-                <a:latin typeface="Noto Sans"/>
-              </a:defRPr>
-            </a:pPr>
-            <a:r>
-              <a:rPr sz="2800" b="1" lang="ja-JP" altLang="en-US">
-                <a:solidFill>
-                  <a:srgbClr val="303437"/>
-                </a:solidFill>
-                <a:latin typeface="Noto Sans"/>
-                <a:ea typeface="Noto Sans CJK JP"/>
-                <a:cs typeface="Noto Sans"/>
-              </a:rPr>
-              <a:t>中国語の言語理解を、共通の基盤で測る</a:t>
-            </a:r>
-          </a:p>
-        </p:txBody>
-      </p:sp>
-      <p:sp>
-        <p:nvSpPr>
-          <p:cNvPr id="3" name="Text Placeholder 2"/>
-          <p:cNvSpPr>
-            <a:spLocks noGrp="1"/>
-          </p:cNvSpPr>
-          <p:nvPr>
-            <p:ph type="body" idx="1"/>
-          </p:nvPr>
-        </p:nvSpPr>
-        <p:spPr>
-          <a:xfrm>
-            <a:off x="594360" y="1463040"/>
-            <a:ext cx="7955279" cy="3044952"/>
-          </a:xfrm>
-        </p:spPr>
-        <p:txBody>
-          <a:bodyPr wrap="square" tIns="91440" bIns="91440">
-            <a:noAutofit/>
-          </a:bodyPr>
-          <a:lstStyle/>
-          <a:p>
-            <a:pPr marL="457200" indent="-355600">
-              <a:lnSpc>
-                <a:spcPts val="2320"/>
-              </a:lnSpc>
-              <a:spcAft>
-                <a:spcPts val="700"/>
-              </a:spcAft>
-              <a:buSzPct val="68205"/>
-              <a:buFont typeface="Noto Sans CJK JP"/>
-              <a:buChar char="●"/>
-              <a:defRPr sz="1950" b="0">
-                <a:solidFill>
-                  <a:srgbClr val="303437"/>
-                </a:solidFill>
-                <a:latin typeface="Noto Sans"/>
-              </a:defRPr>
-            </a:pPr>
-            <a:r>
-              <a:rPr sz="1950" b="0" lang="ja-JP" altLang="en-US">
-                <a:solidFill>
-                  <a:srgbClr val="303437"/>
-                </a:solidFill>
-                <a:latin typeface="Noto Sans"/>
-                <a:ea typeface="Noto Sans CJK JP"/>
-                <a:cs typeface="Noto Sans"/>
-              </a:rPr>
-              <a:t>CLUEチームは、Liang Xu、Hai Hu、Xuanwei Zhangらによる共同プロジェクト。COLING 2020では9種類の中国語理解課題と事前学習モデルの比較を示した。</a:t>
-            </a:r>
-          </a:p>
-          <a:p>
-            <a:pPr marL="457200" indent="-355600">
-              <a:lnSpc>
-                <a:spcPts val="2320"/>
-              </a:lnSpc>
-              <a:spcAft>
-                <a:spcPts val="700"/>
-              </a:spcAft>
-              <a:buSzPct val="68205"/>
-              <a:buFont typeface="Noto Sans CJK JP"/>
-              <a:buChar char="●"/>
-              <a:defRPr sz="1950" b="0">
-                <a:solidFill>
-                  <a:srgbClr val="303437"/>
-                </a:solidFill>
-                <a:latin typeface="Noto Sans"/>
-              </a:defRPr>
-            </a:pPr>
-            <a:r>
-              <a:rPr sz="1950" b="0" lang="ja-JP" altLang="en-US">
-                <a:solidFill>
-                  <a:srgbClr val="303437"/>
-                </a:solidFill>
-                <a:latin typeface="Noto Sans"/>
-                <a:ea typeface="Noto Sans CJK JP"/>
-                <a:cs typeface="Noto Sans"/>
-              </a:rPr>
-              <a:t>CLUEWSC2020はそのうち、指定された代名詞の指示対象を判定する課題。英語中心の評価基盤を補い、中国語の自然な文脈で理解を測る位置付けを持つ。</a:t>
-            </a:r>
-          </a:p>
-          <a:p>
-            <a:pPr marL="457200" indent="-355600">
-              <a:lnSpc>
-                <a:spcPts val="2320"/>
-              </a:lnSpc>
-              <a:spcAft>
-                <a:spcPts val="0"/>
-              </a:spcAft>
-              <a:buSzPct val="68205"/>
-              <a:buFont typeface="Noto Sans CJK JP"/>
-              <a:buChar char="●"/>
-              <a:defRPr sz="1950" b="0">
-                <a:solidFill>
-                  <a:srgbClr val="303437"/>
-                </a:solidFill>
-                <a:latin typeface="Noto Sans"/>
-              </a:defRPr>
-            </a:pPr>
-            <a:r>
-              <a:rPr sz="1950" b="0" lang="ja-JP" altLang="en-US">
-                <a:solidFill>
-                  <a:srgbClr val="303437"/>
-                </a:solidFill>
-                <a:latin typeface="Noto Sans"/>
-                <a:ea typeface="Noto Sans CJK JP"/>
-                <a:cs typeface="Noto Sans"/>
-              </a:rPr>
-              <a:t>元WSCの発想、CLUEでの中国語データ整備、CLEVAでの言語モデル評価という、異なる段階の取り組みがつながっている。</a:t>
-            </a:r>
-          </a:p>
-        </p:txBody>
-      </p:sp>
-      <p:sp>
-        <p:nvSpPr>
-          <p:cNvPr id="4" name="Title 3"/>
-          <p:cNvSpPr>
-            <a:spLocks noGrp="1"/>
-          </p:cNvSpPr>
-          <p:nvPr>
-            <p:ph type="title" idx="2"/>
-          </p:nvPr>
-        </p:nvSpPr>
-        <p:spPr>
-          <a:xfrm>
-            <a:off x="75895" y="0"/>
-            <a:ext cx="8115300" cy="480060"/>
-          </a:xfrm>
-        </p:spPr>
-        <p:txBody>
-          <a:bodyPr wrap="square" lIns="0" rIns="0" tIns="0" bIns="0" anchor="ctr">
-            <a:noAutofit/>
-          </a:bodyPr>
-          <a:lstStyle/>
-          <a:p>
-            <a:pPr algn="l">
-              <a:lnSpc>
-                <a:spcPct val="110000"/>
-              </a:lnSpc>
-              <a:buNone/>
-              <a:defRPr sz="1400" b="0">
-                <a:solidFill>
-                  <a:srgbClr val="303437"/>
-                </a:solidFill>
-                <a:latin typeface="Noto Sans"/>
-              </a:defRPr>
-            </a:pPr>
-            <a:r>
-              <a:rPr sz="1400" b="1" lang="ja-JP" altLang="en-US">
-                <a:solidFill>
-                  <a:srgbClr val="FFFEF8"/>
-                </a:solidFill>
-                <a:latin typeface="Noto Sans"/>
-                <a:ea typeface="Noto Sans CJK JP"/>
-                <a:cs typeface="Noto Sans"/>
-              </a:rPr>
-              <a:t>Appendix: 3. 研究と参考文献</a:t>
-            </a:r>
-          </a:p>
-        </p:txBody>
-      </p:sp>
-      <p:sp>
-        <p:nvSpPr>
-          <p:cNvPr id="5" name="sources"/>
-          <p:cNvSpPr txBox="1"/>
-          <p:nvPr/>
-        </p:nvSpPr>
-        <p:spPr>
-          <a:xfrm>
-            <a:off x="502920" y="4700016"/>
-            <a:ext cx="8183879" cy="530352"/>
-          </a:xfrm>
-          <a:prstGeom prst="rect">
-            <a:avLst/>
-          </a:prstGeom>
-          <a:noFill/>
-        </p:spPr>
-        <p:txBody>
-          <a:bodyPr wrap="square" lIns="0" rIns="0" tIns="0" bIns="0">
-            <a:noAutofit/>
-          </a:bodyPr>
-          <a:lstStyle/>
-          <a:p>
-            <a:pPr algn="l">
-              <a:lnSpc>
-                <a:spcPts val="940"/>
-              </a:lnSpc>
-              <a:spcBef>
-                <a:spcPts val="0"/>
-              </a:spcBef>
-              <a:spcAft>
-                <a:spcPts val="300"/>
-              </a:spcAft>
-              <a:buNone/>
-              <a:defRPr sz="810" b="0">
-                <a:solidFill>
-                  <a:srgbClr val="303437"/>
-                </a:solidFill>
-                <a:latin typeface="Noto Sans"/>
-              </a:defRPr>
-            </a:pPr>
-            <a:r>
-              <a:rPr sz="810" b="0" lang="ja-JP" altLang="en-US">
-                <a:solidFill>
-                  <a:srgbClr val="626669"/>
-                </a:solidFill>
-                <a:latin typeface="Noto Sans"/>
-                <a:ea typeface="Noto Sans CJK JP"/>
-                <a:cs typeface="Noto Sans"/>
-              </a:rPr>
-              <a:t>[1] Xu et al. (2020). CLUE: A Chinese Language Understanding Evaluation Benchmark. COLING, pp.4762–4772.</a:t>
-            </a:r>
-            <a:r>
-              <a:rPr sz="810" b="0" lang="ja-JP" altLang="en-US">
-                <a:solidFill>
-                  <a:srgbClr val="626669"/>
-                </a:solidFill>
-                <a:latin typeface="Noto Sans"/>
-                <a:ea typeface="Noto Sans CJK JP"/>
-                <a:cs typeface="Noto Sans"/>
-              </a:rPr>
-              <a:t>  </a:t>
-            </a:r>
-            <a:r>
-              <a:rPr sz="810" b="0" lang="ja-JP" altLang="en-US">
-                <a:solidFill>
-                  <a:srgbClr val="626669"/>
-                </a:solidFill>
-                <a:latin typeface="Noto Sans"/>
-                <a:ea typeface="Noto Sans CJK JP"/>
-                <a:cs typeface="Noto Sans"/>
-                <a:hlinkClick r:id="rId2"/>
-              </a:rPr>
-              <a:t>https://aclanthology.org/2020.coling-main.419/</a:t>
             </a:r>
           </a:p>
         </p:txBody>
@@ -32807,554 +31675,6 @@
 </p:sld>
 </file>
 
-<file path=ppt/slides/slide60.xml><?xml version="1.0" encoding="utf-8"?>
-<p:sld xmlns:a="http://schemas.openxmlformats.org/drawingml/2006/main" xmlns:p="http://schemas.openxmlformats.org/presentationml/2006/main" xmlns:r="http://schemas.openxmlformats.org/officeDocument/2006/relationships">
-  <p:cSld>
-    <p:spTree>
-      <p:nvGrpSpPr>
-        <p:cNvPr id="1" name=""/>
-        <p:cNvGrpSpPr/>
-        <p:nvPr/>
-      </p:nvGrpSpPr>
-      <p:grpSpPr/>
-      <p:sp>
-        <p:nvSpPr>
-          <p:cNvPr id="2" name="Title 1"/>
-          <p:cNvSpPr>
-            <a:spLocks noGrp="1"/>
-          </p:cNvSpPr>
-          <p:nvPr>
-            <p:ph type="title"/>
-          </p:nvPr>
-        </p:nvSpPr>
-        <p:spPr>
-          <a:xfrm>
-            <a:off x="468172" y="650138"/>
-            <a:ext cx="8206740" cy="616305"/>
-          </a:xfrm>
-        </p:spPr>
-        <p:txBody>
-          <a:bodyPr wrap="square" lIns="0" rIns="0" tIns="0" bIns="0">
-            <a:noAutofit/>
-          </a:bodyPr>
-          <a:lstStyle/>
-          <a:p>
-            <a:pPr algn="l">
-              <a:lnSpc>
-                <a:spcPct val="110000"/>
-              </a:lnSpc>
-              <a:buNone/>
-              <a:defRPr sz="2800" b="0">
-                <a:solidFill>
-                  <a:srgbClr val="303437"/>
-                </a:solidFill>
-                <a:latin typeface="Noto Sans"/>
-              </a:defRPr>
-            </a:pPr>
-            <a:r>
-              <a:rPr sz="2800" b="1" lang="ja-JP" altLang="en-US">
-                <a:solidFill>
-                  <a:srgbClr val="303437"/>
-                </a:solidFill>
-                <a:latin typeface="Noto Sans"/>
-                <a:ea typeface="Noto Sans CJK JP"/>
-                <a:cs typeface="Noto Sans"/>
-              </a:rPr>
-              <a:t>参考文献</a:t>
-            </a:r>
-          </a:p>
-        </p:txBody>
-      </p:sp>
-      <p:sp>
-        <p:nvSpPr>
-          <p:cNvPr id="3" name="Title 2"/>
-          <p:cNvSpPr>
-            <a:spLocks noGrp="1"/>
-          </p:cNvSpPr>
-          <p:nvPr>
-            <p:ph type="title" idx="2"/>
-          </p:nvPr>
-        </p:nvSpPr>
-        <p:spPr>
-          <a:xfrm>
-            <a:off x="75895" y="0"/>
-            <a:ext cx="8115300" cy="480060"/>
-          </a:xfrm>
-        </p:spPr>
-        <p:txBody>
-          <a:bodyPr wrap="square" lIns="0" rIns="0" tIns="0" bIns="0" anchor="ctr">
-            <a:noAutofit/>
-          </a:bodyPr>
-          <a:lstStyle/>
-          <a:p>
-            <a:pPr algn="l">
-              <a:lnSpc>
-                <a:spcPct val="110000"/>
-              </a:lnSpc>
-              <a:buNone/>
-              <a:defRPr sz="1400" b="0">
-                <a:solidFill>
-                  <a:srgbClr val="303437"/>
-                </a:solidFill>
-                <a:latin typeface="Noto Sans"/>
-              </a:defRPr>
-            </a:pPr>
-            <a:r>
-              <a:rPr sz="1400" b="1" lang="ja-JP" altLang="en-US">
-                <a:solidFill>
-                  <a:srgbClr val="FFFEF8"/>
-                </a:solidFill>
-                <a:latin typeface="Noto Sans"/>
-                <a:ea typeface="Noto Sans CJK JP"/>
-                <a:cs typeface="Noto Sans"/>
-              </a:rPr>
-              <a:t>Appendix: 3. 研究と参考文献</a:t>
-            </a:r>
-          </a:p>
-        </p:txBody>
-      </p:sp>
-      <p:sp>
-        <p:nvSpPr>
-          <p:cNvPr id="4" name="TextBox 3"/>
-          <p:cNvSpPr txBox="1"/>
-          <p:nvPr/>
-        </p:nvSpPr>
-        <p:spPr>
-          <a:xfrm>
-            <a:off x="548640" y="1325880"/>
-            <a:ext cx="8046720" cy="585216"/>
-          </a:xfrm>
-          <a:prstGeom prst="rect">
-            <a:avLst/>
-          </a:prstGeom>
-          <a:noFill/>
-        </p:spPr>
-        <p:txBody>
-          <a:bodyPr wrap="square" lIns="0" rIns="0" tIns="0" bIns="0">
-            <a:noAutofit/>
-          </a:bodyPr>
-          <a:lstStyle/>
-          <a:p>
-            <a:pPr algn="l">
-              <a:lnSpc>
-                <a:spcPts val="1920"/>
-              </a:lnSpc>
-              <a:spcBef>
-                <a:spcPts val="0"/>
-              </a:spcBef>
-              <a:spcAft>
-                <a:spcPts val="0"/>
-              </a:spcAft>
-              <a:buNone/>
-              <a:defRPr sz="1700" b="0">
-                <a:solidFill>
-                  <a:srgbClr val="303437"/>
-                </a:solidFill>
-                <a:latin typeface="Noto Sans"/>
-              </a:defRPr>
-            </a:pPr>
-            <a:r>
-              <a:rPr sz="1700" b="1" lang="ja-JP" altLang="en-US">
-                <a:solidFill>
-                  <a:srgbClr val="303437"/>
-                </a:solidFill>
-                <a:latin typeface="Noto Sans"/>
-                <a:ea typeface="Noto Sans CJK JP"/>
-                <a:cs typeface="Noto Sans"/>
-              </a:rPr>
-              <a:t>CLEVA: Chinese Language Models EVAluation Platform</a:t>
-            </a:r>
-          </a:p>
-        </p:txBody>
-      </p:sp>
-      <p:sp>
-        <p:nvSpPr>
-          <p:cNvPr id="5" name="TextBox 4"/>
-          <p:cNvSpPr txBox="1"/>
-          <p:nvPr/>
-        </p:nvSpPr>
-        <p:spPr>
-          <a:xfrm>
-            <a:off x="548640" y="1956815"/>
-            <a:ext cx="8046720" cy="228600"/>
-          </a:xfrm>
-          <a:prstGeom prst="rect">
-            <a:avLst/>
-          </a:prstGeom>
-          <a:noFill/>
-        </p:spPr>
-        <p:txBody>
-          <a:bodyPr wrap="square" lIns="0" rIns="0" tIns="0" bIns="0">
-            <a:noAutofit/>
-          </a:bodyPr>
-          <a:lstStyle/>
-          <a:p>
-            <a:pPr algn="l">
-              <a:lnSpc>
-                <a:spcPts val="1404"/>
-              </a:lnSpc>
-              <a:spcBef>
-                <a:spcPts val="0"/>
-              </a:spcBef>
-              <a:spcAft>
-                <a:spcPts val="0"/>
-              </a:spcAft>
-              <a:buNone/>
-              <a:defRPr sz="1200" b="0">
-                <a:solidFill>
-                  <a:srgbClr val="303437"/>
-                </a:solidFill>
-                <a:latin typeface="Noto Sans"/>
-              </a:defRPr>
-            </a:pPr>
-            <a:r>
-              <a:rPr sz="1200" b="0" lang="ja-JP" altLang="en-US">
-                <a:solidFill>
-                  <a:srgbClr val="626669"/>
-                </a:solidFill>
-                <a:latin typeface="Noto Sans"/>
-                <a:ea typeface="Noto Sans CJK JP"/>
-                <a:cs typeface="Noto Sans"/>
-              </a:rPr>
-              <a:t>Li et al. · 2023 · EMNLP System Demonstrations</a:t>
-            </a:r>
-          </a:p>
-        </p:txBody>
-      </p:sp>
-      <p:sp>
-        <p:nvSpPr>
-          <p:cNvPr id="6" name="TextBox 5"/>
-          <p:cNvSpPr txBox="1"/>
-          <p:nvPr/>
-        </p:nvSpPr>
-        <p:spPr>
-          <a:xfrm>
-            <a:off x="548640" y="2240280"/>
-            <a:ext cx="8046720" cy="457200"/>
-          </a:xfrm>
-          <a:prstGeom prst="rect">
-            <a:avLst/>
-          </a:prstGeom>
-          <a:noFill/>
-        </p:spPr>
-        <p:txBody>
-          <a:bodyPr wrap="square" lIns="0" rIns="0" tIns="0" bIns="0">
-            <a:noAutofit/>
-          </a:bodyPr>
-          <a:lstStyle/>
-          <a:p>
-            <a:pPr algn="l">
-              <a:lnSpc>
-                <a:spcPts val="1823"/>
-              </a:lnSpc>
-              <a:spcBef>
-                <a:spcPts val="0"/>
-              </a:spcBef>
-              <a:spcAft>
-                <a:spcPts val="0"/>
-              </a:spcAft>
-              <a:buNone/>
-              <a:defRPr sz="1600" b="0">
-                <a:solidFill>
-                  <a:srgbClr val="303437"/>
-                </a:solidFill>
-                <a:latin typeface="Noto Sans"/>
-              </a:defRPr>
-            </a:pPr>
-            <a:r>
-              <a:rPr sz="1600" b="0" lang="ja-JP" altLang="en-US">
-                <a:solidFill>
-                  <a:srgbClr val="303437"/>
-                </a:solidFill>
-                <a:latin typeface="Noto Sans"/>
-                <a:ea typeface="Noto Sans CJK JP"/>
-                <a:cs typeface="Noto Sans"/>
-              </a:rPr>
-              <a:t>中国語モデルの多面的評価基盤。付録B.1.1でCLUEWSCの採用と共参照例を示す。</a:t>
-            </a:r>
-          </a:p>
-        </p:txBody>
-      </p:sp>
-      <p:sp>
-        <p:nvSpPr>
-          <p:cNvPr id="7" name="TextBox 6"/>
-          <p:cNvSpPr txBox="1"/>
-          <p:nvPr/>
-        </p:nvSpPr>
-        <p:spPr>
-          <a:xfrm>
-            <a:off x="548640" y="2752344"/>
-            <a:ext cx="8046720" cy="228600"/>
-          </a:xfrm>
-          <a:prstGeom prst="rect">
-            <a:avLst/>
-          </a:prstGeom>
-          <a:noFill/>
-        </p:spPr>
-        <p:txBody>
-          <a:bodyPr wrap="square" lIns="0" rIns="0" tIns="0" bIns="0">
-            <a:noAutofit/>
-          </a:bodyPr>
-          <a:lstStyle/>
-          <a:p>
-            <a:pPr algn="l">
-              <a:lnSpc>
-                <a:spcPts val="1263"/>
-              </a:lnSpc>
-              <a:spcBef>
-                <a:spcPts val="0"/>
-              </a:spcBef>
-              <a:spcAft>
-                <a:spcPts val="0"/>
-              </a:spcAft>
-              <a:buNone/>
-              <a:defRPr sz="1080" b="0">
-                <a:solidFill>
-                  <a:srgbClr val="303437"/>
-                </a:solidFill>
-                <a:latin typeface="Noto Sans"/>
-              </a:defRPr>
-            </a:pPr>
-            <a:r>
-              <a:rPr sz="1080" b="0" lang="ja-JP" altLang="en-US">
-                <a:solidFill>
-                  <a:srgbClr val="2166AC"/>
-                </a:solidFill>
-                <a:latin typeface="Noto Sans"/>
-                <a:ea typeface="Noto Sans CJK JP"/>
-                <a:cs typeface="Noto Sans"/>
-                <a:hlinkClick r:id="rId2"/>
-              </a:rPr>
-              <a:t>https://aclanthology.org/2023.emnlp-demo.17/</a:t>
-            </a:r>
-          </a:p>
-        </p:txBody>
-      </p:sp>
-      <p:sp>
-        <p:nvSpPr>
-          <p:cNvPr id="8" name="TextBox 7"/>
-          <p:cNvSpPr txBox="1"/>
-          <p:nvPr/>
-        </p:nvSpPr>
-        <p:spPr>
-          <a:xfrm>
-            <a:off x="548640" y="3063239"/>
-            <a:ext cx="8046720" cy="585216"/>
-          </a:xfrm>
-          <a:prstGeom prst="rect">
-            <a:avLst/>
-          </a:prstGeom>
-          <a:noFill/>
-        </p:spPr>
-        <p:txBody>
-          <a:bodyPr wrap="square" lIns="0" rIns="0" tIns="0" bIns="0">
-            <a:noAutofit/>
-          </a:bodyPr>
-          <a:lstStyle/>
-          <a:p>
-            <a:pPr algn="l">
-              <a:lnSpc>
-                <a:spcPts val="1920"/>
-              </a:lnSpc>
-              <a:spcBef>
-                <a:spcPts val="0"/>
-              </a:spcBef>
-              <a:spcAft>
-                <a:spcPts val="0"/>
-              </a:spcAft>
-              <a:buNone/>
-              <a:defRPr sz="1700" b="0">
-                <a:solidFill>
-                  <a:srgbClr val="303437"/>
-                </a:solidFill>
-                <a:latin typeface="Noto Sans"/>
-              </a:defRPr>
-            </a:pPr>
-            <a:r>
-              <a:rPr sz="1700" b="1" lang="ja-JP" altLang="en-US">
-                <a:solidFill>
-                  <a:srgbClr val="303437"/>
-                </a:solidFill>
-                <a:latin typeface="Noto Sans"/>
-                <a:ea typeface="Noto Sans CJK JP"/>
-                <a:cs typeface="Noto Sans"/>
-              </a:rPr>
-              <a:t>CLEVACoreferenceResolutionScenario and Converter</a:t>
-            </a:r>
-          </a:p>
-        </p:txBody>
-      </p:sp>
-      <p:sp>
-        <p:nvSpPr>
-          <p:cNvPr id="9" name="TextBox 8"/>
-          <p:cNvSpPr txBox="1"/>
-          <p:nvPr/>
-        </p:nvSpPr>
-        <p:spPr>
-          <a:xfrm>
-            <a:off x="548640" y="3694175"/>
-            <a:ext cx="8046720" cy="228600"/>
-          </a:xfrm>
-          <a:prstGeom prst="rect">
-            <a:avLst/>
-          </a:prstGeom>
-          <a:noFill/>
-        </p:spPr>
-        <p:txBody>
-          <a:bodyPr wrap="square" lIns="0" rIns="0" tIns="0" bIns="0">
-            <a:noAutofit/>
-          </a:bodyPr>
-          <a:lstStyle/>
-          <a:p>
-            <a:pPr algn="l">
-              <a:lnSpc>
-                <a:spcPts val="1404"/>
-              </a:lnSpc>
-              <a:spcBef>
-                <a:spcPts val="0"/>
-              </a:spcBef>
-              <a:spcAft>
-                <a:spcPts val="0"/>
-              </a:spcAft>
-              <a:buNone/>
-              <a:defRPr sz="1200" b="0">
-                <a:solidFill>
-                  <a:srgbClr val="303437"/>
-                </a:solidFill>
-                <a:latin typeface="Noto Sans"/>
-              </a:defRPr>
-            </a:pPr>
-            <a:r>
-              <a:rPr sz="1200" b="0" lang="ja-JP" altLang="en-US">
-                <a:solidFill>
-                  <a:srgbClr val="626669"/>
-                </a:solidFill>
-                <a:latin typeface="Noto Sans"/>
-                <a:ea typeface="Noto Sans CJK JP"/>
-                <a:cs typeface="Noto Sans"/>
-              </a:rPr>
-              <a:t>Stanford CRFM · 2023 · HELM v0.4.0 implementation</a:t>
-            </a:r>
-          </a:p>
-        </p:txBody>
-      </p:sp>
-      <p:sp>
-        <p:nvSpPr>
-          <p:cNvPr id="10" name="TextBox 9"/>
-          <p:cNvSpPr txBox="1"/>
-          <p:nvPr/>
-        </p:nvSpPr>
-        <p:spPr>
-          <a:xfrm>
-            <a:off x="548640" y="3977639"/>
-            <a:ext cx="8046720" cy="457200"/>
-          </a:xfrm>
-          <a:prstGeom prst="rect">
-            <a:avLst/>
-          </a:prstGeom>
-          <a:noFill/>
-        </p:spPr>
-        <p:txBody>
-          <a:bodyPr wrap="square" lIns="0" rIns="0" tIns="0" bIns="0">
-            <a:noAutofit/>
-          </a:bodyPr>
-          <a:lstStyle/>
-          <a:p>
-            <a:pPr algn="l">
-              <a:lnSpc>
-                <a:spcPts val="1823"/>
-              </a:lnSpc>
-              <a:spcBef>
-                <a:spcPts val="0"/>
-              </a:spcBef>
-              <a:spcAft>
-                <a:spcPts val="0"/>
-              </a:spcAft>
-              <a:buNone/>
-              <a:defRPr sz="1600" b="0">
-                <a:solidFill>
-                  <a:srgbClr val="303437"/>
-                </a:solidFill>
-                <a:latin typeface="Noto Sans"/>
-              </a:defRPr>
-            </a:pPr>
-            <a:r>
-              <a:rPr sz="1600" b="0" lang="ja-JP" altLang="en-US">
-                <a:solidFill>
-                  <a:srgbClr val="303437"/>
-                </a:solidFill>
-                <a:latin typeface="Noto Sans"/>
-                <a:ea typeface="Noto Sans CJK JP"/>
-                <a:cs typeface="Noto Sans"/>
-              </a:rPr>
-              <a:t>テンプレートから入力と参照を作る。塊と代名詞の一致を問う中国語の例を含む。</a:t>
-            </a:r>
-          </a:p>
-        </p:txBody>
-      </p:sp>
-      <p:sp>
-        <p:nvSpPr>
-          <p:cNvPr id="11" name="TextBox 10"/>
-          <p:cNvSpPr txBox="1"/>
-          <p:nvPr/>
-        </p:nvSpPr>
-        <p:spPr>
-          <a:xfrm>
-            <a:off x="548640" y="4489704"/>
-            <a:ext cx="8046720" cy="228600"/>
-          </a:xfrm>
-          <a:prstGeom prst="rect">
-            <a:avLst/>
-          </a:prstGeom>
-          <a:noFill/>
-        </p:spPr>
-        <p:txBody>
-          <a:bodyPr wrap="square" lIns="0" rIns="0" tIns="0" bIns="0">
-            <a:noAutofit/>
-          </a:bodyPr>
-          <a:lstStyle/>
-          <a:p>
-            <a:pPr algn="l">
-              <a:lnSpc>
-                <a:spcPts val="1263"/>
-              </a:lnSpc>
-              <a:spcBef>
-                <a:spcPts val="0"/>
-              </a:spcBef>
-              <a:spcAft>
-                <a:spcPts val="0"/>
-              </a:spcAft>
-              <a:buNone/>
-              <a:defRPr sz="1080" b="0">
-                <a:solidFill>
-                  <a:srgbClr val="303437"/>
-                </a:solidFill>
-                <a:latin typeface="Noto Sans"/>
-              </a:defRPr>
-            </a:pPr>
-            <a:r>
-              <a:rPr sz="1080" b="0" lang="ja-JP" altLang="en-US">
-                <a:solidFill>
-                  <a:srgbClr val="2166AC"/>
-                </a:solidFill>
-                <a:latin typeface="Noto Sans"/>
-                <a:ea typeface="Noto Sans CJK JP"/>
-                <a:cs typeface="Noto Sans"/>
-                <a:hlinkClick r:id="rId3"/>
-              </a:rPr>
-              <a:t>https://github.com/stanford-crfm/helm/blob/v0.4.0/src/helm/benchmark/scenarios/cleva_scenario.py</a:t>
-            </a:r>
-          </a:p>
-        </p:txBody>
-      </p:sp>
-    </p:spTree>
-  </p:cSld>
-  <p:clrMapOvr>
-    <a:masterClrMapping/>
-  </p:clrMapOvr>
-</p:sld>
-</file>
-
 <file path=ppt/slides/slide7.xml><?xml version="1.0" encoding="utf-8"?>
 <p:sld xmlns:a="http://schemas.openxmlformats.org/drawingml/2006/main" xmlns:p="http://schemas.openxmlformats.org/presentationml/2006/main" xmlns:r="http://schemas.openxmlformats.org/officeDocument/2006/relationships">
   <p:cSld>
@@ -33494,36 +31814,6 @@
               <a:t>「煮汁」と「塊」の両方が出てくる文章で、代名詞と動作の対象を結び付ける問題になっている。</a:t>
             </a:r>
           </a:p>
-          <a:p>
-            <a:pPr marL="457200" indent="-355600">
-              <a:lnSpc>
-                <a:spcPts val="2320"/>
-              </a:lnSpc>
-              <a:spcAft>
-                <a:spcPts val="0"/>
-              </a:spcAft>
-              <a:buSzPct val="68205"/>
-              <a:buFont typeface="Noto Sans CJK JP"/>
-              <a:buChar char="●"/>
-              <a:defRPr sz="1950" b="0">
-                <a:solidFill>
-                  <a:srgbClr val="303437"/>
-                </a:solidFill>
-                <a:latin typeface="Noto Sans"/>
-              </a:defRPr>
-            </a:pPr>
-            <a:r>
-              <a:rPr sz="1950" b="0" lang="ja-JP" altLang="en-US">
-                <a:solidFill>
-                  <a:srgbClr val="303437"/>
-                </a:solidFill>
-                <a:latin typeface="Noto Sans"/>
-                <a:ea typeface="Noto Sans CJK JP"/>
-                <a:cs typeface="Noto Sans"/>
-              </a:rPr>
-              <a:t>この問題は、HELMにあるCLEVAの共参照解決シナリオでも説明例に使われている。</a:t>
-            </a:r>
-          </a:p>
         </p:txBody>
       </p:sp>
       <p:sp>
@@ -33647,63 +31937,6 @@
                 <a:hlinkClick r:id="rId2"/>
               </a:rPr>
               <a:t>https://storage.googleapis.com/cluebenchmark/tasks/cluewsc2020_public.zip</a:t>
-            </a:r>
-          </a:p>
-          <a:p>
-            <a:pPr>
-              <a:lnSpc>
-                <a:spcPts val="940"/>
-              </a:lnSpc>
-              <a:spcAft>
-                <a:spcPts val="300"/>
-              </a:spcAft>
-              <a:buNone/>
-              <a:defRPr sz="810" b="0">
-                <a:solidFill>
-                  <a:srgbClr val="303437"/>
-                </a:solidFill>
-                <a:latin typeface="Noto Sans"/>
-              </a:defRPr>
-            </a:pPr>
-            <a:r>
-              <a:rPr sz="810" b="0" lang="ja-JP" altLang="en-US">
-                <a:solidFill>
-                  <a:srgbClr val="626669"/>
-                </a:solidFill>
-                <a:latin typeface="Noto Sans"/>
-                <a:ea typeface="Noto Sans CJK JP"/>
-                <a:cs typeface="Noto Sans"/>
-              </a:rPr>
-              <a:t>[2] Stanford CRFM. CLEVACoreferenceResolutionScenario / Converter. HELM v0.4.0.</a:t>
-            </a:r>
-          </a:p>
-          <a:p>
-            <a:pPr>
-              <a:lnSpc>
-                <a:spcPts val="940"/>
-              </a:lnSpc>
-              <a:spcAft>
-                <a:spcPts val="300"/>
-              </a:spcAft>
-              <a:buNone/>
-              <a:defRPr sz="810" b="0">
-                <a:solidFill>
-                  <a:srgbClr val="303437"/>
-                </a:solidFill>
-                <a:latin typeface="Noto Sans"/>
-              </a:defRPr>
-            </a:pPr>
-            <a:r>
-              <a:rPr sz="810" b="0" lang="ja-JP" altLang="en-US">
-                <a:solidFill>
-                  <a:srgbClr val="626669"/>
-                </a:solidFill>
-                <a:latin typeface="Noto Sans"/>
-                <a:ea typeface="Noto Sans CJK JP"/>
-                <a:cs typeface="Noto Sans"/>
-                <a:hlinkClick r:id="rId3"/>
-              </a:rPr>
-              <a:t>https://github.com/stanford-crfm/helm/blob/v0.4.0/src/helm/benchmark/scenarios/cleva_scenario.py</a:t>
             </a:r>
           </a:p>
         </p:txBody>
@@ -34640,36 +32873,6 @@
               <a:t>蒋盈波、准教授、同業者という複数の人物が出てくる。誰が誰を招いたかを、文の主語が変わっても追う必要がある。</a:t>
             </a:r>
           </a:p>
-          <a:p>
-            <a:pPr marL="457200" indent="-355600">
-              <a:lnSpc>
-                <a:spcPts val="2320"/>
-              </a:lnSpc>
-              <a:spcAft>
-                <a:spcPts val="0"/>
-              </a:spcAft>
-              <a:buSzPct val="68205"/>
-              <a:buFont typeface="Noto Sans CJK JP"/>
-              <a:buChar char="●"/>
-              <a:defRPr sz="1950" b="0">
-                <a:solidFill>
-                  <a:srgbClr val="303437"/>
-                </a:solidFill>
-                <a:latin typeface="Noto Sans"/>
-              </a:defRPr>
-            </a:pPr>
-            <a:r>
-              <a:rPr sz="1950" b="0" lang="ja-JP" altLang="en-US">
-                <a:solidFill>
-                  <a:srgbClr val="303437"/>
-                </a:solidFill>
-                <a:latin typeface="Noto Sans"/>
-                <a:ea typeface="Noto Sans CJK JP"/>
-                <a:cs typeface="Noto Sans"/>
-              </a:rPr>
-              <a:t>CLEVAの論文でも、この文章と二つの指定箇所が共参照解決の例に使われている。</a:t>
-            </a:r>
-          </a:p>
         </p:txBody>
       </p:sp>
       <p:sp>
@@ -34793,57 +32996,6 @@
                 <a:hlinkClick r:id="rId2"/>
               </a:rPr>
               <a:t>https://storage.googleapis.com/cluebenchmark/tasks/cluewsc2020_public.zip</a:t>
-            </a:r>
-          </a:p>
-          <a:p>
-            <a:pPr>
-              <a:lnSpc>
-                <a:spcPts val="940"/>
-              </a:lnSpc>
-              <a:spcAft>
-                <a:spcPts val="300"/>
-              </a:spcAft>
-              <a:buNone/>
-              <a:defRPr sz="810" b="0">
-                <a:solidFill>
-                  <a:srgbClr val="303437"/>
-                </a:solidFill>
-                <a:latin typeface="Noto Sans"/>
-              </a:defRPr>
-            </a:pPr>
-            <a:r>
-              <a:rPr sz="810" b="0" lang="ja-JP" altLang="en-US">
-                <a:solidFill>
-                  <a:srgbClr val="626669"/>
-                </a:solidFill>
-                <a:latin typeface="Noto Sans"/>
-                <a:ea typeface="Noto Sans CJK JP"/>
-                <a:cs typeface="Noto Sans"/>
-              </a:rPr>
-              <a:t>[2] Li et al. (2023). CLEVA: Chinese Language Models EVAluation Platform. EMNLP System Demonstrations.</a:t>
-            </a:r>
-            <a:r>
-              <a:rPr sz="810" b="0" lang="ja-JP" altLang="en-US">
-                <a:solidFill>
-                  <a:srgbClr val="626669"/>
-                </a:solidFill>
-                <a:latin typeface="Noto Sans"/>
-                <a:ea typeface="Noto Sans CJK JP"/>
-                <a:cs typeface="Noto Sans"/>
-              </a:rPr>
-              <a:t>  </a:t>
-            </a:r>
-            <a:r>
-              <a:rPr sz="810" b="0" lang="ja-JP" altLang="en-US">
-                <a:solidFill>
-                  <a:srgbClr val="626669"/>
-                </a:solidFill>
-                <a:latin typeface="Noto Sans"/>
-                <a:ea typeface="Noto Sans CJK JP"/>
-                <a:cs typeface="Noto Sans"/>
-                <a:hlinkClick r:id="rId3"/>
-              </a:rPr>
-              <a:t>https://aclanthology.org/2023.emnlp-demo.17/</a:t>
             </a:r>
           </a:p>
         </p:txBody>

</xml_diff>